<commit_message>
refactor: replace allure with pytest html reports
Co-authored-by: NghiaHuynh <huynhtrongnghia1996@users.noreply.github.com>
</commit_message>
<xml_diff>
--- a/reports/automation-test-framework-design.pptx
+++ b/reports/automation-test-framework-design.pptx
@@ -191,7 +191,7 @@
                   <a:srgbClr val="333333"/>
                 </a:solidFill>
               </a:rPr>
-              <a:t>- Python 3.12, pytest, Playwright Python, httpx, psycopg, allure-pytest, pydantic-settings, loguru, ruff, pyright, Git, Jenkins.</a:t>
+              <a:t>- Python 3.12, pytest, Playwright Python, pytest-html, httpx, psycopg, pydantic-settings, loguru, ruff, pyright, Git, Jenkins.</a:t>
             </a:r>
           </a:p>
         </p:txBody>
@@ -225,7 +225,7 @@
                   <a:srgbClr val="777777"/>
                 </a:solidFill>
               </a:rPr>
-              <a:t>Python Automation Framework | Slide 1</a:t>
+              <a:t>Python pytest-html Automation Framework | Slide 1</a:t>
             </a:r>
           </a:p>
         </p:txBody>
@@ -384,7 +384,17 @@
                   <a:srgbClr val="333333"/>
                 </a:solidFill>
               </a:rPr>
-              <a:t>- Allure report va Jenkins CI/CD.</a:t>
+              <a:t>- pytest-html report mot file HTML de mo va share.</a:t>
+            </a:r>
+          </a:p>
+          <a:p>
+            <a:r>
+              <a:rPr lang="en-US" sz="1600">
+                <a:solidFill>
+                  <a:srgbClr val="333333"/>
+                </a:solidFill>
+              </a:rPr>
+              <a:t>- Screenshot/log/artifact khi fail.</a:t>
             </a:r>
           </a:p>
         </p:txBody>
@@ -418,7 +428,7 @@
                   <a:srgbClr val="777777"/>
                 </a:solidFill>
               </a:rPr>
-              <a:t>Python Automation Framework | Slide 2</a:t>
+              <a:t>Python pytest-html Automation Framework | Slide 2</a:t>
             </a:r>
           </a:p>
         </p:txBody>
@@ -567,7 +577,17 @@
                   <a:srgbClr val="333333"/>
                 </a:solidFill>
               </a:rPr>
-              <a:t>- src/test/resources/report-html: html va images resources.</a:t>
+              <a:t>- reports/report.html la HTML report runtime.</a:t>
+            </a:r>
+          </a:p>
+          <a:p>
+            <a:r>
+              <a:rPr lang="en-US" sz="1600">
+                <a:solidFill>
+                  <a:srgbClr val="333333"/>
+                </a:solidFill>
+              </a:rPr>
+              <a:t>- test-results luu screenshots va attachments.</a:t>
             </a:r>
           </a:p>
         </p:txBody>
@@ -601,7 +621,7 @@
                   <a:srgbClr val="777777"/>
                 </a:solidFill>
               </a:rPr>
-              <a:t>Python Automation Framework | Slide 3</a:t>
+              <a:t>Python pytest-html Automation Framework | Slide 3</a:t>
             </a:r>
           </a:p>
         </p:txBody>
@@ -794,7 +814,7 @@
                   <a:srgbClr val="777777"/>
                 </a:solidFill>
               </a:rPr>
-              <a:t>Python Automation Framework | Slide 4</a:t>
+              <a:t>Python pytest-html Automation Framework | Slide 4</a:t>
             </a:r>
           </a:p>
         </p:txBody>
@@ -977,7 +997,7 @@
                   <a:srgbClr val="777777"/>
                 </a:solidFill>
               </a:rPr>
-              <a:t>Python Automation Framework | Slide 5</a:t>
+              <a:t>Python pytest-html Automation Framework | Slide 5</a:t>
             </a:r>
           </a:p>
         </p:txBody>
@@ -1126,7 +1146,7 @@
                   <a:srgbClr val="333333"/>
                 </a:solidFill>
               </a:rPr>
-              <a:t>- Request/response co the attach vao Allure.</a:t>
+              <a:t>- Response/debug artifact ghi vao test-results/attachments.</a:t>
             </a:r>
           </a:p>
         </p:txBody>
@@ -1160,7 +1180,7 @@
                   <a:srgbClr val="777777"/>
                 </a:solidFill>
               </a:rPr>
-              <a:t>Python Automation Framework | Slide 6</a:t>
+              <a:t>Python pytest-html Automation Framework | Slide 6</a:t>
             </a:r>
           </a:p>
         </p:txBody>
@@ -1289,27 +1309,17 @@
                   <a:srgbClr val="333333"/>
                 </a:solidFill>
               </a:rPr>
-              <a:t>- allure-pytest sinh allure-results.</a:t>
-            </a:r>
-          </a:p>
-          <a:p>
-            <a:r>
-              <a:rPr lang="en-US" sz="1600">
-                <a:solidFill>
-                  <a:srgbClr val="333333"/>
-                </a:solidFill>
-              </a:rPr>
-              <a:t>- Allure HTML report o allure-report/index.html.</a:t>
-            </a:r>
-          </a:p>
-          <a:p>
-            <a:r>
-              <a:rPr lang="en-US" sz="1600">
-                <a:solidFill>
-                  <a:srgbClr val="333333"/>
-                </a:solidFill>
-              </a:rPr>
-              <a:t>- Screenshot attach khi fail.</a:t>
+              <a:t>- pytest-html sinh reports/report.html.</a:t>
+            </a:r>
+          </a:p>
+          <a:p>
+            <a:r>
+              <a:rPr lang="en-US" sz="1600">
+                <a:solidFill>
+                  <a:srgbClr val="333333"/>
+                </a:solidFill>
+              </a:rPr>
+              <a:t>- Screenshot fail luu o test-results/screenshots va hien link trong report.</a:t>
             </a:r>
           </a:p>
           <a:p>
@@ -1320,6 +1330,16 @@
                 </a:solidFill>
               </a:rPr>
               <a:t>- loguru ghi logs/automation.log.</a:t>
+            </a:r>
+          </a:p>
+          <a:p>
+            <a:r>
+              <a:rPr lang="en-US" sz="1600">
+                <a:solidFill>
+                  <a:srgbClr val="333333"/>
+                </a:solidFill>
+              </a:rPr>
+              <a:t>- Khong can Java hoac report CLI rieng.</a:t>
             </a:r>
           </a:p>
         </p:txBody>
@@ -1353,7 +1373,7 @@
                   <a:srgbClr val="777777"/>
                 </a:solidFill>
               </a:rPr>
-              <a:t>Python Automation Framework | Slide 7</a:t>
+              <a:t>Python pytest-html Automation Framework | Slide 7</a:t>
             </a:r>
           </a:p>
         </p:txBody>
@@ -1536,7 +1556,7 @@
                   <a:srgbClr val="777777"/>
                 </a:solidFill>
               </a:rPr>
-              <a:t>Python Automation Framework | Slide 8</a:t>
+              <a:t>Python pytest-html Automation Framework | Slide 8</a:t>
             </a:r>
           </a:p>
         </p:txBody>

</xml_diff>